<commit_message>
fix: clean world map rendering - remove banding, update guides & docs
- Removed horizontal latitude grid lines that caused prominent banding artifacts
- Removed CSS linear-gradient background (replaced with solid #0b1929 ocean)
- Improved country fill contrast: #1a3a5c full opacity with #254d73 borders
- Kept only subtle vertical longitude lines (no horizontal bands)
- Improved ocean radial glow gradient for clean dark theme look
- Updated PROJECT_GUIDE.md to v2.1 with Session 13 changelog
- Regenerated 4 PowerPoint guides (v2.1) with updated map descriptions
- Updated generate_ppts.py version and map-related slide content

Build: 0 errors, 2543 modules
</commit_message>
<xml_diff>
--- a/AirZeta_Admin_Guide_KR.pptx
+++ b/AirZeta_Admin_Guide_KR.pptx
@@ -5655,23 +5655,23 @@
               </a:defRPr>
             </a:pPr>
             <a:r>
-              <a:t>- TopoJSON 기반 실제 세계 지도 렌더링</a:t>
-            </a:r>
-          </a:p>
-          <a:p>
-            <a:pPr lvl="1">
-              <a:spcBef>
-                <a:spcPts val="300"/>
-              </a:spcBef>
-              <a:defRPr sz="1200">
-                <a:solidFill>
-                  <a:srgbClr val="E8EAED"/>
-                </a:solidFill>
-                <a:latin typeface="Malgun Gothic"/>
-              </a:defRPr>
-            </a:pPr>
-            <a:r>
-              <a:t>- 85+ IATA 공항 마커 표시</a:t>
+              <a:t>- TopoJSON 기반 실제 세계 지도 렌더링 (깔끔한 다크 테마)</a:t>
+            </a:r>
+          </a:p>
+          <a:p>
+            <a:pPr lvl="1">
+              <a:spcBef>
+                <a:spcPts val="300"/>
+              </a:spcBef>
+              <a:defRPr sz="1200">
+                <a:solidFill>
+                  <a:srgbClr val="E8EAED"/>
+                </a:solidFill>
+                <a:latin typeface="Malgun Gothic"/>
+              </a:defRPr>
+            </a:pPr>
+            <a:r>
+              <a:t>- 85+ IATA 공항 마커 표시 (고정 크기 - 줌 시 확대되지 않음)</a:t>
             </a:r>
           </a:p>
           <a:p>
@@ -5703,23 +5703,39 @@
               </a:defRPr>
             </a:pPr>
             <a:r>
-              <a:t>- 확대/축소 (마우스 휠), 이동 (드래그), 더블클릭 확대</a:t>
-            </a:r>
-          </a:p>
-          <a:p>
-            <a:pPr lvl="1">
-              <a:spcBef>
-                <a:spcPts val="300"/>
-              </a:spcBef>
-              <a:defRPr sz="1200">
-                <a:solidFill>
-                  <a:srgbClr val="E8EAED"/>
-                </a:solidFill>
-                <a:latin typeface="Malgun Gothic"/>
-              </a:defRPr>
-            </a:pPr>
-            <a:r>
-              <a:t>- ICN(인천) 중심 지도 배치</a:t>
+              <a:t>- 확대/축소 (마우스 휠/더블클릭) - 마우스 포인터 위치 중심 줌</a:t>
+            </a:r>
+          </a:p>
+          <a:p>
+            <a:pPr lvl="1">
+              <a:spcBef>
+                <a:spcPts val="300"/>
+              </a:spcBef>
+              <a:defRPr sz="1200">
+                <a:solidFill>
+                  <a:srgbClr val="E8EAED"/>
+                </a:solidFill>
+                <a:latin typeface="Malgun Gothic"/>
+              </a:defRPr>
+            </a:pPr>
+            <a:r>
+              <a:t>- ICN(인천) 중심 지도 배치, 깨끗한 해양 배경</a:t>
+            </a:r>
+          </a:p>
+          <a:p>
+            <a:pPr lvl="1">
+              <a:spcBef>
+                <a:spcPts val="300"/>
+              </a:spcBef>
+              <a:defRPr sz="1200">
+                <a:solidFill>
+                  <a:srgbClr val="E8EAED"/>
+                </a:solidFill>
+                <a:latin typeface="Malgun Gothic"/>
+              </a:defRPr>
+            </a:pPr>
+            <a:r>
+              <a:t>- 드래그로 지도 이동, Reset Zoom 버튼으로 초기 위치 복원</a:t>
             </a:r>
           </a:p>
           <a:p>

</xml_diff>